<commit_message>
feat: restore and update Abhijay L. G. details across team catalog, documentation, presentations, and biometrics
</commit_message>
<xml_diff>
--- a/PROJECT_NEXUS_PRESENTATION.pptx
+++ b/PROJECT_NEXUS_PRESENTATION.pptx
@@ -592,7 +592,7 @@
           <a:lstStyle/>
           <a:p>
             <a:r>
-              <a:t>ADAPTIVE PERSONALIZATION (Presented by Abhijay L. G.):</a:t>
+              <a:t>ADAPTIVE PERSONALIZATION (Presented by Team STI25CS):</a:t>
             </a:r>
           </a:p>
           <a:p>
@@ -667,7 +667,7 @@
           <a:lstStyle/>
           <a:p>
             <a:r>
-              <a:t>MATHEMATICAL &amp; TOKEN FORMULATION (Presented by Abhijay L. G.):</a:t>
+              <a:t>MATHEMATICAL &amp; TOKEN FORMULATION (Presented by Team STI25CS):</a:t>
             </a:r>
           </a:p>
           <a:p>
@@ -917,7 +917,7 @@
           <a:lstStyle/>
           <a:p>
             <a:r>
-              <a:t>TEAM CONTRIBUTIONS (Presented by Bhadra G. S.):</a:t>
+              <a:t>TEAM CONTRIBUTIONS (Presented by Bhadra G. S. &amp; Abhijay L. G.):</a:t>
             </a:r>
           </a:p>
           <a:p>
@@ -947,7 +947,7 @@
           </a:p>
           <a:p>
             <a:r>
-              <a:t>- Abhijay: Central Java orchestrator, event bus, SQLite storage, and adaptive personalization.</a:t>
+              <a:t>- Abhijay: Python AI perception core, central orchestrator, SQLite storage, and adaptive personalization.</a:t>
             </a:r>
           </a:p>
         </p:txBody>
@@ -1277,7 +1277,7 @@
           <a:lstStyle/>
           <a:p>
             <a:r>
-              <a:t>CORE IDEATION (Presented by Bhadra G. S. &amp; Abhijay L. G.):</a:t>
+              <a:t>CORE IDEATION (Presented by Bhadra G. S. &amp; Team STI25CS):</a:t>
             </a:r>
           </a:p>
           <a:p>
@@ -1352,7 +1352,7 @@
           <a:lstStyle/>
           <a:p>
             <a:r>
-              <a:t>SYSTEM ARCHITECTURE (Presented by Bhadra G. S. &amp; Abhijay L. G.):</a:t>
+              <a:t>SYSTEM ARCHITECTURE (Presented by Bhadra G. S. &amp; Team STI25CS):</a:t>
             </a:r>
           </a:p>
           <a:p>
@@ -1447,7 +1447,7 @@
           <a:lstStyle/>
           <a:p>
             <a:r>
-              <a:t>CONCURRENCY ARCHITECTURE (Presented by Abhijay L. G. &amp; Dia M. Joby):</a:t>
+              <a:t>CONCURRENCY ARCHITECTURE (Presented by Team STI25CS &amp; Dia M. Joby):</a:t>
             </a:r>
           </a:p>
           <a:p>
@@ -1752,7 +1752,7 @@
           <a:lstStyle/>
           <a:p>
             <a:r>
-              <a:t>REASONING &amp; PROMPTING (Presented by Abhijay L. G.):</a:t>
+              <a:t>REASONING &amp; PROMPTING (Presented by Team STI25CS):</a:t>
             </a:r>
           </a:p>
           <a:p>
@@ -8677,7 +8677,7 @@
               </a:defRPr>
             </a:pPr>
             <a:r>
-              <a:t>Central Orchestration &amp; Learning</a:t>
+              <a:t>Python AI Core &amp; Orchestration</a:t>
             </a:r>
           </a:p>
           <a:p>
@@ -8690,7 +8690,7 @@
               </a:defRPr>
             </a:pPr>
             <a:r>
-              <a:t>Architected NexusCore, MultimodalEventBus, SQLite JDBC persistence, and the Closed-Loop Adaptive Personalization Engine.</a:t>
+              <a:t>Architected Python AI perception microservice (FERPlus ONNX, ViT gender, OpenCV gestures), NexusCore, and closed-loop personalization.</a:t>
             </a:r>
           </a:p>
         </p:txBody>

</xml_diff>